<commit_message>
Add verified independent T1K accuracy to third slide
</commit_message>
<xml_diff>
--- a/slide_prep/hackathon-wrapup/slides.pptx
+++ b/slide_prep/hackathon-wrapup/slides.pptx
@@ -808,18 +808,136 @@
           <a:lstStyle/>
           <a:p>
             <a:r>
-              <a:t>3. DogoHLA</a:t>
+              <a:t>3. DogoHLA and T1K reference performance</a:t>
             </a:r>
           </a:p>
           <a:p/>
           <a:p>
             <a:r>
-              <a:t>Dawn presents the method. This slide contains only her original DogoHLA image,</a:t>
-            </a:r>
-          </a:p>
-          <a:p>
-            <a:r>
-              <a:t>retained at its native resolution from the org repository.</a:t>
+              <a:t>Dawn presents DogoHLA. The adjacent table reports T1K, using IPD 3.65 and</a:t>
+            </a:r>
+          </a:p>
+          <a:p>
+            <a:r>
+              <a:t>four-field output, as the established-method reference in the independent</a:t>
+            </a:r>
+          </a:p>
+          <a:p>
+            <a:r>
+              <a:t>evaluations. It contains no DogoHLA performance claim.</a:t>
+            </a:r>
+          </a:p>
+          <a:p/>
+          <a:p>
+            <a:r>
+              <a:t>The 64-donor matched assembly-truth cohort has 16 EAS, 16 SAS, 16 EUR and</a:t>
+            </a:r>
+          </a:p>
+          <a:p>
+            <a:r>
+              <a:t>16 AFR donors. All 64 T1K runs completed. Across eight genes, two-field</a:t>
+            </a:r>
+          </a:p>
+          <a:p>
+            <a:r>
+              <a:t>accuracy is 495/509 (97.25%); strict four-numeric-field accuracy is 163/323</a:t>
+            </a:r>
+          </a:p>
+          <a:p>
+            <a:r>
+              <a:t>(50.46%). At four fields, 317/323 eligible genotypes are resolved; the six</a:t>
+            </a:r>
+          </a:p>
+          <a:p>
+            <a:r>
+              <a:t>unresolved genotypes count as incorrect. Two-field truth requires exact CDS</a:t>
+            </a:r>
+          </a:p>
+          <a:p>
+            <a:r>
+              <a:t>identity, and four-field truth exact genomic identity for both haplotypes.</a:t>
+            </a:r>
+          </a:p>
+          <a:p>
+            <a:r>
+              <a:t>Expression suffixes are ignored in the four-numeric-field endpoint. Ambiguous</a:t>
+            </a:r>
+          </a:p>
+          <a:p>
+            <a:r>
+              <a:t>predictions must satisfy the scorer's strict matching rule. These resolutions</a:t>
+            </a:r>
+          </a:p>
+          <a:p>
+            <a:r>
+              <a:t>use different eligible subsets and should not be treated as a matched-subset</a:t>
+            </a:r>
+          </a:p>
+          <a:p>
+            <a:r>
+              <a:t>comparison. The evaluation donors and known families are excluded from panel</a:t>
+            </a:r>
+          </a:p>
+          <a:p>
+            <a:r>
+              <a:t>references. The cohort includes prospectively reserved validation donors;</a:t>
+            </a:r>
+          </a:p>
+          <a:p>
+            <a:r>
+              <a:t>prior assembly availability is documented in the evaluation protocol.</a:t>
+            </a:r>
+          </a:p>
+          <a:p/>
+          <a:p>
+            <a:r>
+              <a:t>The separate Gourraud experimental-truth cohort has 946 donors, zero graph-donor</a:t>
+            </a:r>
+          </a:p>
+          <a:p>
+            <a:r>
+              <a:t>or known-family overlap, and five HLA genes. T1K completed 945 runs; one audited</a:t>
+            </a:r>
+          </a:p>
+          <a:p>
+            <a:r>
+              <a:t>terminal failure contributes zero correct credit. Two-field accuracy is</a:t>
+            </a:r>
+          </a:p>
+          <a:p>
+            <a:r>
+              <a:t>4,437/4,723 (93.94%). Experimental truth supports two fields only; four-field</a:t>
+            </a:r>
+          </a:p>
+          <a:p>
+            <a:r>
+              <a:t>accuracy is unavailable. A, B, C, DRB1 and DQB1 are evaluated.</a:t>
+            </a:r>
+          </a:p>
+          <a:p/>
+          <a:p>
+            <a:r>
+              <a:t>The slide totals were independently recomputed from T1K per-gene score rows.</a:t>
+            </a:r>
+          </a:p>
+          <a:p>
+            <a:r>
+              <a:t>All 64 assembly-cohort and 945 experimental-cohort raw T1K output hashes matched</a:t>
+            </a:r>
+          </a:p>
+          <a:p>
+            <a:r>
+              <a:t>the frozen provenance. Sources: hla-spechla-pg/series20260918/analysis and its</a:t>
+            </a:r>
+          </a:p>
+          <a:p>
+            <a:r>
+              <a:t>gourraud subdirectory in the analysis repository. T1K-only score snapshots and</a:t>
+            </a:r>
+          </a:p>
+          <a:p>
+            <a:r>
+              <a:t>the compact summary are included in data/ beside this deck.</a:t>
             </a:r>
           </a:p>
           <a:p/>

</xml_diff>